<commit_message>
Update Build Slides with icon library slide
</commit_message>
<xml_diff>
--- a/Peach State Build Slides.pptx
+++ b/Peach State Build Slides.pptx
@@ -31,6 +31,7 @@
     <p:sldId id="279" r:id="rId30"/>
     <p:sldId id="280" r:id="rId31"/>
     <p:sldId id="281" r:id="rId32"/>
+    <p:sldId id="282" r:id="rId33"/>
   </p:sldIdLst>
   <p:sldSz cx="12191695" cy="6858000" type="screen4x3"/>
   <p:notesSz cx="6858000" cy="9144000"/>
@@ -13416,6 +13417,2449 @@
 </file>
 
 <file path=ppt/slides/slide26.xml><?xml version="1.0" encoding="utf-8"?>
+<p:sld xmlns:a="http://schemas.openxmlformats.org/drawingml/2006/main" xmlns:p="http://schemas.openxmlformats.org/presentationml/2006/main" xmlns:r="http://schemas.openxmlformats.org/officeDocument/2006/relationships">
+  <p:cSld>
+    <p:spTree>
+      <p:nvGrpSpPr>
+        <p:cNvPr id="1" name=""/>
+        <p:cNvGrpSpPr/>
+        <p:nvPr/>
+      </p:nvGrpSpPr>
+      <p:grpSpPr/>
+      <p:sp>
+        <p:nvSpPr>
+          <p:cNvPr id="2" name="Rectangle 1"/>
+          <p:cNvSpPr/>
+          <p:nvPr/>
+        </p:nvSpPr>
+        <p:spPr>
+          <a:xfrm>
+            <a:off x="0" y="0"/>
+            <a:ext cx="12191695" cy="6858000"/>
+          </a:xfrm>
+          <a:prstGeom prst="rect">
+            <a:avLst/>
+          </a:prstGeom>
+          <a:solidFill>
+            <a:srgbClr val="FFFFFF"/>
+          </a:solidFill>
+          <a:ln>
+            <a:noFill/>
+          </a:ln>
+          <a:effectLst/>
+        </p:spPr>
+        <p:style>
+          <a:lnRef idx="1">
+            <a:schemeClr val="accent1"/>
+          </a:lnRef>
+          <a:fillRef idx="3">
+            <a:schemeClr val="accent1"/>
+          </a:fillRef>
+          <a:effectRef idx="2">
+            <a:schemeClr val="accent1"/>
+          </a:effectRef>
+          <a:fontRef idx="minor">
+            <a:schemeClr val="lt1"/>
+          </a:fontRef>
+        </p:style>
+        <p:txBody>
+          <a:bodyPr rtlCol="0" anchor="ctr"/>
+          <a:lstStyle/>
+          <a:p>
+            <a:pPr algn="ctr"/>
+          </a:p>
+        </p:txBody>
+      </p:sp>
+      <p:sp>
+        <p:nvSpPr>
+          <p:cNvPr id="3" name="Rectangle 2"/>
+          <p:cNvSpPr/>
+          <p:nvPr/>
+        </p:nvSpPr>
+        <p:spPr>
+          <a:xfrm>
+            <a:off x="868680" y="713232"/>
+            <a:ext cx="1645920" cy="63500"/>
+          </a:xfrm>
+          <a:prstGeom prst="rect">
+            <a:avLst/>
+          </a:prstGeom>
+          <a:solidFill>
+            <a:srgbClr val="E1251B"/>
+          </a:solidFill>
+          <a:ln>
+            <a:noFill/>
+          </a:ln>
+          <a:effectLst/>
+        </p:spPr>
+        <p:style>
+          <a:lnRef idx="1">
+            <a:schemeClr val="accent1"/>
+          </a:lnRef>
+          <a:fillRef idx="3">
+            <a:schemeClr val="accent1"/>
+          </a:fillRef>
+          <a:effectRef idx="2">
+            <a:schemeClr val="accent1"/>
+          </a:effectRef>
+          <a:fontRef idx="minor">
+            <a:schemeClr val="lt1"/>
+          </a:fontRef>
+        </p:style>
+        <p:txBody>
+          <a:bodyPr rtlCol="0" anchor="ctr"/>
+          <a:lstStyle/>
+          <a:p>
+            <a:pPr algn="ctr"/>
+          </a:p>
+        </p:txBody>
+      </p:sp>
+      <p:sp>
+        <p:nvSpPr>
+          <p:cNvPr id="4" name="TextBox 3"/>
+          <p:cNvSpPr txBox="1"/>
+          <p:nvPr/>
+        </p:nvSpPr>
+        <p:spPr>
+          <a:xfrm>
+            <a:off x="822960" y="868680"/>
+            <a:ext cx="10515600" cy="914400"/>
+          </a:xfrm>
+          <a:prstGeom prst="rect">
+            <a:avLst/>
+          </a:prstGeom>
+          <a:noFill/>
+        </p:spPr>
+        <p:txBody>
+          <a:bodyPr wrap="square" anchor="t">
+            <a:spAutoFit/>
+          </a:bodyPr>
+          <a:lstStyle/>
+          <a:p>
+            <a:pPr algn="l">
+              <a:lnSpc>
+                <a:spcPct val="105000"/>
+              </a:lnSpc>
+              <a:spcAft>
+                <a:spcPts val="600"/>
+              </a:spcAft>
+            </a:pPr>
+            <a:r>
+              <a:rPr sz="3200" b="1">
+                <a:solidFill>
+                  <a:srgbClr val="1A1D1F"/>
+                </a:solidFill>
+                <a:latin typeface="Helvetica Neue"/>
+              </a:rPr>
+              <a:t>Icon Library - Delete Before Presenting</a:t>
+            </a:r>
+          </a:p>
+        </p:txBody>
+      </p:sp>
+      <p:sp>
+        <p:nvSpPr>
+          <p:cNvPr id="5" name="TextBox 4"/>
+          <p:cNvSpPr txBox="1"/>
+          <p:nvPr/>
+        </p:nvSpPr>
+        <p:spPr>
+          <a:xfrm>
+            <a:off x="841248" y="1554480"/>
+            <a:ext cx="10332720" cy="548640"/>
+          </a:xfrm>
+          <a:prstGeom prst="rect">
+            <a:avLst/>
+          </a:prstGeom>
+          <a:noFill/>
+        </p:spPr>
+        <p:txBody>
+          <a:bodyPr wrap="square" anchor="t">
+            <a:spAutoFit/>
+          </a:bodyPr>
+          <a:lstStyle/>
+          <a:p>
+            <a:pPr algn="l">
+              <a:lnSpc>
+                <a:spcPct val="105000"/>
+              </a:lnSpc>
+              <a:spcAft>
+                <a:spcPts val="600"/>
+              </a:spcAft>
+            </a:pPr>
+            <a:r>
+              <a:rPr sz="1800" b="0">
+                <a:solidFill>
+                  <a:srgbClr val="53575A"/>
+                </a:solidFill>
+                <a:latin typeface="Helvetica Neue"/>
+              </a:rPr>
+              <a:t>Copy any red or gray icon onto your working slides, then delete this slide before presenting.</a:t>
+            </a:r>
+          </a:p>
+        </p:txBody>
+      </p:sp>
+      <p:pic>
+        <p:nvPicPr>
+          <p:cNvPr id="6" name="Picture 5" descr="check.png"/>
+          <p:cNvPicPr>
+            <a:picLocks noChangeAspect="1"/>
+          </p:cNvPicPr>
+          <p:nvPr/>
+        </p:nvPicPr>
+        <p:blipFill>
+          <a:blip r:embed="rId2"/>
+          <a:stretch>
+            <a:fillRect/>
+          </a:stretch>
+        </p:blipFill>
+        <p:spPr>
+          <a:xfrm>
+            <a:off x="1100297" y="1874519"/>
+            <a:ext cx="530352" cy="530352"/>
+          </a:xfrm>
+          <a:prstGeom prst="rect">
+            <a:avLst/>
+          </a:prstGeom>
+        </p:spPr>
+      </p:pic>
+      <p:pic>
+        <p:nvPicPr>
+          <p:cNvPr id="7" name="Picture 6" descr="check.png"/>
+          <p:cNvPicPr>
+            <a:picLocks noChangeAspect="1"/>
+          </p:cNvPicPr>
+          <p:nvPr/>
+        </p:nvPicPr>
+        <p:blipFill>
+          <a:blip r:embed="rId3"/>
+          <a:stretch>
+            <a:fillRect/>
+          </a:stretch>
+        </p:blipFill>
+        <p:spPr>
+          <a:xfrm>
+            <a:off x="1722089" y="1874519"/>
+            <a:ext cx="530352" cy="530352"/>
+          </a:xfrm>
+          <a:prstGeom prst="rect">
+            <a:avLst/>
+          </a:prstGeom>
+        </p:spPr>
+      </p:pic>
+      <p:sp>
+        <p:nvSpPr>
+          <p:cNvPr id="8" name="TextBox 7"/>
+          <p:cNvSpPr txBox="1"/>
+          <p:nvPr/>
+        </p:nvSpPr>
+        <p:spPr>
+          <a:xfrm>
+            <a:off x="548640" y="2441447"/>
+            <a:ext cx="2255459" cy="274320"/>
+          </a:xfrm>
+          <a:prstGeom prst="rect">
+            <a:avLst/>
+          </a:prstGeom>
+          <a:noFill/>
+        </p:spPr>
+        <p:txBody>
+          <a:bodyPr wrap="square" anchor="t">
+            <a:spAutoFit/>
+          </a:bodyPr>
+          <a:lstStyle/>
+          <a:p>
+            <a:pPr algn="ctr">
+              <a:lnSpc>
+                <a:spcPct val="105000"/>
+              </a:lnSpc>
+              <a:spcAft>
+                <a:spcPts val="600"/>
+              </a:spcAft>
+            </a:pPr>
+            <a:r>
+              <a:rPr sz="800" b="0">
+                <a:solidFill>
+                  <a:srgbClr val="53575A"/>
+                </a:solidFill>
+                <a:latin typeface="Helvetica Neue"/>
+              </a:rPr>
+              <a:t>check</a:t>
+            </a:r>
+          </a:p>
+        </p:txBody>
+      </p:sp>
+      <p:pic>
+        <p:nvPicPr>
+          <p:cNvPr id="9" name="Picture 8" descr="click.png"/>
+          <p:cNvPicPr>
+            <a:picLocks noChangeAspect="1"/>
+          </p:cNvPicPr>
+          <p:nvPr/>
+        </p:nvPicPr>
+        <p:blipFill>
+          <a:blip r:embed="rId4"/>
+          <a:stretch>
+            <a:fillRect/>
+          </a:stretch>
+        </p:blipFill>
+        <p:spPr>
+          <a:xfrm>
+            <a:off x="3310036" y="1874519"/>
+            <a:ext cx="530352" cy="530352"/>
+          </a:xfrm>
+          <a:prstGeom prst="rect">
+            <a:avLst/>
+          </a:prstGeom>
+        </p:spPr>
+      </p:pic>
+      <p:pic>
+        <p:nvPicPr>
+          <p:cNvPr id="10" name="Picture 9" descr="click.png"/>
+          <p:cNvPicPr>
+            <a:picLocks noChangeAspect="1"/>
+          </p:cNvPicPr>
+          <p:nvPr/>
+        </p:nvPicPr>
+        <p:blipFill>
+          <a:blip r:embed="rId5"/>
+          <a:stretch>
+            <a:fillRect/>
+          </a:stretch>
+        </p:blipFill>
+        <p:spPr>
+          <a:xfrm>
+            <a:off x="3931828" y="1874519"/>
+            <a:ext cx="530352" cy="530352"/>
+          </a:xfrm>
+          <a:prstGeom prst="rect">
+            <a:avLst/>
+          </a:prstGeom>
+        </p:spPr>
+      </p:pic>
+      <p:sp>
+        <p:nvSpPr>
+          <p:cNvPr id="11" name="TextBox 10"/>
+          <p:cNvSpPr txBox="1"/>
+          <p:nvPr/>
+        </p:nvSpPr>
+        <p:spPr>
+          <a:xfrm>
+            <a:off x="2758379" y="2441447"/>
+            <a:ext cx="2255459" cy="274320"/>
+          </a:xfrm>
+          <a:prstGeom prst="rect">
+            <a:avLst/>
+          </a:prstGeom>
+          <a:noFill/>
+        </p:spPr>
+        <p:txBody>
+          <a:bodyPr wrap="square" anchor="t">
+            <a:spAutoFit/>
+          </a:bodyPr>
+          <a:lstStyle/>
+          <a:p>
+            <a:pPr algn="ctr">
+              <a:lnSpc>
+                <a:spcPct val="105000"/>
+              </a:lnSpc>
+              <a:spcAft>
+                <a:spcPts val="600"/>
+              </a:spcAft>
+            </a:pPr>
+            <a:r>
+              <a:rPr sz="800" b="0">
+                <a:solidFill>
+                  <a:srgbClr val="53575A"/>
+                </a:solidFill>
+                <a:latin typeface="Helvetica Neue"/>
+              </a:rPr>
+              <a:t>click</a:t>
+            </a:r>
+          </a:p>
+        </p:txBody>
+      </p:sp>
+      <p:pic>
+        <p:nvPicPr>
+          <p:cNvPr id="12" name="Picture 11" descr="clock.png"/>
+          <p:cNvPicPr>
+            <a:picLocks noChangeAspect="1"/>
+          </p:cNvPicPr>
+          <p:nvPr/>
+        </p:nvPicPr>
+        <p:blipFill>
+          <a:blip r:embed="rId6"/>
+          <a:stretch>
+            <a:fillRect/>
+          </a:stretch>
+        </p:blipFill>
+        <p:spPr>
+          <a:xfrm>
+            <a:off x="5519775" y="1874519"/>
+            <a:ext cx="530352" cy="530352"/>
+          </a:xfrm>
+          <a:prstGeom prst="rect">
+            <a:avLst/>
+          </a:prstGeom>
+        </p:spPr>
+      </p:pic>
+      <p:pic>
+        <p:nvPicPr>
+          <p:cNvPr id="13" name="Picture 12" descr="clock.png"/>
+          <p:cNvPicPr>
+            <a:picLocks noChangeAspect="1"/>
+          </p:cNvPicPr>
+          <p:nvPr/>
+        </p:nvPicPr>
+        <p:blipFill>
+          <a:blip r:embed="rId7"/>
+          <a:stretch>
+            <a:fillRect/>
+          </a:stretch>
+        </p:blipFill>
+        <p:spPr>
+          <a:xfrm>
+            <a:off x="6141567" y="1874519"/>
+            <a:ext cx="530352" cy="530352"/>
+          </a:xfrm>
+          <a:prstGeom prst="rect">
+            <a:avLst/>
+          </a:prstGeom>
+        </p:spPr>
+      </p:pic>
+      <p:sp>
+        <p:nvSpPr>
+          <p:cNvPr id="14" name="TextBox 13"/>
+          <p:cNvSpPr txBox="1"/>
+          <p:nvPr/>
+        </p:nvSpPr>
+        <p:spPr>
+          <a:xfrm>
+            <a:off x="4968118" y="2441447"/>
+            <a:ext cx="2255459" cy="274320"/>
+          </a:xfrm>
+          <a:prstGeom prst="rect">
+            <a:avLst/>
+          </a:prstGeom>
+          <a:noFill/>
+        </p:spPr>
+        <p:txBody>
+          <a:bodyPr wrap="square" anchor="t">
+            <a:spAutoFit/>
+          </a:bodyPr>
+          <a:lstStyle/>
+          <a:p>
+            <a:pPr algn="ctr">
+              <a:lnSpc>
+                <a:spcPct val="105000"/>
+              </a:lnSpc>
+              <a:spcAft>
+                <a:spcPts val="600"/>
+              </a:spcAft>
+            </a:pPr>
+            <a:r>
+              <a:rPr sz="800" b="0">
+                <a:solidFill>
+                  <a:srgbClr val="53575A"/>
+                </a:solidFill>
+                <a:latin typeface="Helvetica Neue"/>
+              </a:rPr>
+              <a:t>clock</a:t>
+            </a:r>
+          </a:p>
+        </p:txBody>
+      </p:sp>
+      <p:pic>
+        <p:nvPicPr>
+          <p:cNvPr id="15" name="Picture 14" descr="close.png"/>
+          <p:cNvPicPr>
+            <a:picLocks noChangeAspect="1"/>
+          </p:cNvPicPr>
+          <p:nvPr/>
+        </p:nvPicPr>
+        <p:blipFill>
+          <a:blip r:embed="rId8"/>
+          <a:stretch>
+            <a:fillRect/>
+          </a:stretch>
+        </p:blipFill>
+        <p:spPr>
+          <a:xfrm>
+            <a:off x="7729514" y="1874519"/>
+            <a:ext cx="530352" cy="530352"/>
+          </a:xfrm>
+          <a:prstGeom prst="rect">
+            <a:avLst/>
+          </a:prstGeom>
+        </p:spPr>
+      </p:pic>
+      <p:pic>
+        <p:nvPicPr>
+          <p:cNvPr id="16" name="Picture 15" descr="close.png"/>
+          <p:cNvPicPr>
+            <a:picLocks noChangeAspect="1"/>
+          </p:cNvPicPr>
+          <p:nvPr/>
+        </p:nvPicPr>
+        <p:blipFill>
+          <a:blip r:embed="rId9"/>
+          <a:stretch>
+            <a:fillRect/>
+          </a:stretch>
+        </p:blipFill>
+        <p:spPr>
+          <a:xfrm>
+            <a:off x="8351306" y="1874519"/>
+            <a:ext cx="530352" cy="530352"/>
+          </a:xfrm>
+          <a:prstGeom prst="rect">
+            <a:avLst/>
+          </a:prstGeom>
+        </p:spPr>
+      </p:pic>
+      <p:sp>
+        <p:nvSpPr>
+          <p:cNvPr id="17" name="TextBox 16"/>
+          <p:cNvSpPr txBox="1"/>
+          <p:nvPr/>
+        </p:nvSpPr>
+        <p:spPr>
+          <a:xfrm>
+            <a:off x="7177857" y="2441447"/>
+            <a:ext cx="2255459" cy="274320"/>
+          </a:xfrm>
+          <a:prstGeom prst="rect">
+            <a:avLst/>
+          </a:prstGeom>
+          <a:noFill/>
+        </p:spPr>
+        <p:txBody>
+          <a:bodyPr wrap="square" anchor="t">
+            <a:spAutoFit/>
+          </a:bodyPr>
+          <a:lstStyle/>
+          <a:p>
+            <a:pPr algn="ctr">
+              <a:lnSpc>
+                <a:spcPct val="105000"/>
+              </a:lnSpc>
+              <a:spcAft>
+                <a:spcPts val="600"/>
+              </a:spcAft>
+            </a:pPr>
+            <a:r>
+              <a:rPr sz="800" b="0">
+                <a:solidFill>
+                  <a:srgbClr val="53575A"/>
+                </a:solidFill>
+                <a:latin typeface="Helvetica Neue"/>
+              </a:rPr>
+              <a:t>close</a:t>
+            </a:r>
+          </a:p>
+        </p:txBody>
+      </p:sp>
+      <p:pic>
+        <p:nvPicPr>
+          <p:cNvPr id="18" name="Picture 17" descr="email.png"/>
+          <p:cNvPicPr>
+            <a:picLocks noChangeAspect="1"/>
+          </p:cNvPicPr>
+          <p:nvPr/>
+        </p:nvPicPr>
+        <p:blipFill>
+          <a:blip r:embed="rId10"/>
+          <a:stretch>
+            <a:fillRect/>
+          </a:stretch>
+        </p:blipFill>
+        <p:spPr>
+          <a:xfrm>
+            <a:off x="9939253" y="1874519"/>
+            <a:ext cx="530352" cy="530352"/>
+          </a:xfrm>
+          <a:prstGeom prst="rect">
+            <a:avLst/>
+          </a:prstGeom>
+        </p:spPr>
+      </p:pic>
+      <p:pic>
+        <p:nvPicPr>
+          <p:cNvPr id="19" name="Picture 18" descr="email.png"/>
+          <p:cNvPicPr>
+            <a:picLocks noChangeAspect="1"/>
+          </p:cNvPicPr>
+          <p:nvPr/>
+        </p:nvPicPr>
+        <p:blipFill>
+          <a:blip r:embed="rId11"/>
+          <a:stretch>
+            <a:fillRect/>
+          </a:stretch>
+        </p:blipFill>
+        <p:spPr>
+          <a:xfrm>
+            <a:off x="10561045" y="1874519"/>
+            <a:ext cx="530352" cy="530352"/>
+          </a:xfrm>
+          <a:prstGeom prst="rect">
+            <a:avLst/>
+          </a:prstGeom>
+        </p:spPr>
+      </p:pic>
+      <p:sp>
+        <p:nvSpPr>
+          <p:cNvPr id="20" name="TextBox 19"/>
+          <p:cNvSpPr txBox="1"/>
+          <p:nvPr/>
+        </p:nvSpPr>
+        <p:spPr>
+          <a:xfrm>
+            <a:off x="9387596" y="2441447"/>
+            <a:ext cx="2255459" cy="274320"/>
+          </a:xfrm>
+          <a:prstGeom prst="rect">
+            <a:avLst/>
+          </a:prstGeom>
+          <a:noFill/>
+        </p:spPr>
+        <p:txBody>
+          <a:bodyPr wrap="square" anchor="t">
+            <a:spAutoFit/>
+          </a:bodyPr>
+          <a:lstStyle/>
+          <a:p>
+            <a:pPr algn="ctr">
+              <a:lnSpc>
+                <a:spcPct val="105000"/>
+              </a:lnSpc>
+              <a:spcAft>
+                <a:spcPts val="600"/>
+              </a:spcAft>
+            </a:pPr>
+            <a:r>
+              <a:rPr sz="800" b="0">
+                <a:solidFill>
+                  <a:srgbClr val="53575A"/>
+                </a:solidFill>
+                <a:latin typeface="Helvetica Neue"/>
+              </a:rPr>
+              <a:t>email</a:t>
+            </a:r>
+          </a:p>
+        </p:txBody>
+      </p:sp>
+      <p:pic>
+        <p:nvPicPr>
+          <p:cNvPr id="21" name="Picture 20" descr="employee.png"/>
+          <p:cNvPicPr>
+            <a:picLocks noChangeAspect="1"/>
+          </p:cNvPicPr>
+          <p:nvPr/>
+        </p:nvPicPr>
+        <p:blipFill>
+          <a:blip r:embed="rId12"/>
+          <a:stretch>
+            <a:fillRect/>
+          </a:stretch>
+        </p:blipFill>
+        <p:spPr>
+          <a:xfrm>
+            <a:off x="1100297" y="2743199"/>
+            <a:ext cx="530352" cy="530352"/>
+          </a:xfrm>
+          <a:prstGeom prst="rect">
+            <a:avLst/>
+          </a:prstGeom>
+        </p:spPr>
+      </p:pic>
+      <p:pic>
+        <p:nvPicPr>
+          <p:cNvPr id="22" name="Picture 21" descr="employee.png"/>
+          <p:cNvPicPr>
+            <a:picLocks noChangeAspect="1"/>
+          </p:cNvPicPr>
+          <p:nvPr/>
+        </p:nvPicPr>
+        <p:blipFill>
+          <a:blip r:embed="rId13"/>
+          <a:stretch>
+            <a:fillRect/>
+          </a:stretch>
+        </p:blipFill>
+        <p:spPr>
+          <a:xfrm>
+            <a:off x="1722089" y="2743199"/>
+            <a:ext cx="530352" cy="530352"/>
+          </a:xfrm>
+          <a:prstGeom prst="rect">
+            <a:avLst/>
+          </a:prstGeom>
+        </p:spPr>
+      </p:pic>
+      <p:sp>
+        <p:nvSpPr>
+          <p:cNvPr id="23" name="TextBox 22"/>
+          <p:cNvSpPr txBox="1"/>
+          <p:nvPr/>
+        </p:nvSpPr>
+        <p:spPr>
+          <a:xfrm>
+            <a:off x="548640" y="3310127"/>
+            <a:ext cx="2255459" cy="274320"/>
+          </a:xfrm>
+          <a:prstGeom prst="rect">
+            <a:avLst/>
+          </a:prstGeom>
+          <a:noFill/>
+        </p:spPr>
+        <p:txBody>
+          <a:bodyPr wrap="square" anchor="t">
+            <a:spAutoFit/>
+          </a:bodyPr>
+          <a:lstStyle/>
+          <a:p>
+            <a:pPr algn="ctr">
+              <a:lnSpc>
+                <a:spcPct val="105000"/>
+              </a:lnSpc>
+              <a:spcAft>
+                <a:spcPts val="600"/>
+              </a:spcAft>
+            </a:pPr>
+            <a:r>
+              <a:rPr sz="800" b="0">
+                <a:solidFill>
+                  <a:srgbClr val="53575A"/>
+                </a:solidFill>
+                <a:latin typeface="Helvetica Neue"/>
+              </a:rPr>
+              <a:t>employee</a:t>
+            </a:r>
+          </a:p>
+        </p:txBody>
+      </p:sp>
+      <p:pic>
+        <p:nvPicPr>
+          <p:cNvPr id="24" name="Picture 23" descr="fleet.png"/>
+          <p:cNvPicPr>
+            <a:picLocks noChangeAspect="1"/>
+          </p:cNvPicPr>
+          <p:nvPr/>
+        </p:nvPicPr>
+        <p:blipFill>
+          <a:blip r:embed="rId14"/>
+          <a:stretch>
+            <a:fillRect/>
+          </a:stretch>
+        </p:blipFill>
+        <p:spPr>
+          <a:xfrm>
+            <a:off x="3310036" y="2743199"/>
+            <a:ext cx="530352" cy="530352"/>
+          </a:xfrm>
+          <a:prstGeom prst="rect">
+            <a:avLst/>
+          </a:prstGeom>
+        </p:spPr>
+      </p:pic>
+      <p:pic>
+        <p:nvPicPr>
+          <p:cNvPr id="25" name="Picture 24" descr="fleet.png"/>
+          <p:cNvPicPr>
+            <a:picLocks noChangeAspect="1"/>
+          </p:cNvPicPr>
+          <p:nvPr/>
+        </p:nvPicPr>
+        <p:blipFill>
+          <a:blip r:embed="rId15"/>
+          <a:stretch>
+            <a:fillRect/>
+          </a:stretch>
+        </p:blipFill>
+        <p:spPr>
+          <a:xfrm>
+            <a:off x="3931828" y="2743199"/>
+            <a:ext cx="530352" cy="530352"/>
+          </a:xfrm>
+          <a:prstGeom prst="rect">
+            <a:avLst/>
+          </a:prstGeom>
+        </p:spPr>
+      </p:pic>
+      <p:sp>
+        <p:nvSpPr>
+          <p:cNvPr id="26" name="TextBox 25"/>
+          <p:cNvSpPr txBox="1"/>
+          <p:nvPr/>
+        </p:nvSpPr>
+        <p:spPr>
+          <a:xfrm>
+            <a:off x="2758379" y="3310127"/>
+            <a:ext cx="2255459" cy="274320"/>
+          </a:xfrm>
+          <a:prstGeom prst="rect">
+            <a:avLst/>
+          </a:prstGeom>
+          <a:noFill/>
+        </p:spPr>
+        <p:txBody>
+          <a:bodyPr wrap="square" anchor="t">
+            <a:spAutoFit/>
+          </a:bodyPr>
+          <a:lstStyle/>
+          <a:p>
+            <a:pPr algn="ctr">
+              <a:lnSpc>
+                <a:spcPct val="105000"/>
+              </a:lnSpc>
+              <a:spcAft>
+                <a:spcPts val="600"/>
+              </a:spcAft>
+            </a:pPr>
+            <a:r>
+              <a:rPr sz="800" b="0">
+                <a:solidFill>
+                  <a:srgbClr val="53575A"/>
+                </a:solidFill>
+                <a:latin typeface="Helvetica Neue"/>
+              </a:rPr>
+              <a:t>fleet</a:t>
+            </a:r>
+          </a:p>
+        </p:txBody>
+      </p:sp>
+      <p:pic>
+        <p:nvPicPr>
+          <p:cNvPr id="27" name="Picture 26" descr="gear.png"/>
+          <p:cNvPicPr>
+            <a:picLocks noChangeAspect="1"/>
+          </p:cNvPicPr>
+          <p:nvPr/>
+        </p:nvPicPr>
+        <p:blipFill>
+          <a:blip r:embed="rId16"/>
+          <a:stretch>
+            <a:fillRect/>
+          </a:stretch>
+        </p:blipFill>
+        <p:spPr>
+          <a:xfrm>
+            <a:off x="5519775" y="2743199"/>
+            <a:ext cx="530352" cy="530352"/>
+          </a:xfrm>
+          <a:prstGeom prst="rect">
+            <a:avLst/>
+          </a:prstGeom>
+        </p:spPr>
+      </p:pic>
+      <p:pic>
+        <p:nvPicPr>
+          <p:cNvPr id="28" name="Picture 27" descr="gear.png"/>
+          <p:cNvPicPr>
+            <a:picLocks noChangeAspect="1"/>
+          </p:cNvPicPr>
+          <p:nvPr/>
+        </p:nvPicPr>
+        <p:blipFill>
+          <a:blip r:embed="rId17"/>
+          <a:stretch>
+            <a:fillRect/>
+          </a:stretch>
+        </p:blipFill>
+        <p:spPr>
+          <a:xfrm>
+            <a:off x="6141567" y="2743199"/>
+            <a:ext cx="530352" cy="530352"/>
+          </a:xfrm>
+          <a:prstGeom prst="rect">
+            <a:avLst/>
+          </a:prstGeom>
+        </p:spPr>
+      </p:pic>
+      <p:sp>
+        <p:nvSpPr>
+          <p:cNvPr id="29" name="TextBox 28"/>
+          <p:cNvSpPr txBox="1"/>
+          <p:nvPr/>
+        </p:nvSpPr>
+        <p:spPr>
+          <a:xfrm>
+            <a:off x="4968118" y="3310127"/>
+            <a:ext cx="2255459" cy="274320"/>
+          </a:xfrm>
+          <a:prstGeom prst="rect">
+            <a:avLst/>
+          </a:prstGeom>
+          <a:noFill/>
+        </p:spPr>
+        <p:txBody>
+          <a:bodyPr wrap="square" anchor="t">
+            <a:spAutoFit/>
+          </a:bodyPr>
+          <a:lstStyle/>
+          <a:p>
+            <a:pPr algn="ctr">
+              <a:lnSpc>
+                <a:spcPct val="105000"/>
+              </a:lnSpc>
+              <a:spcAft>
+                <a:spcPts val="600"/>
+              </a:spcAft>
+            </a:pPr>
+            <a:r>
+              <a:rPr sz="800" b="0">
+                <a:solidFill>
+                  <a:srgbClr val="53575A"/>
+                </a:solidFill>
+                <a:latin typeface="Helvetica Neue"/>
+              </a:rPr>
+              <a:t>gear</a:t>
+            </a:r>
+          </a:p>
+        </p:txBody>
+      </p:sp>
+      <p:pic>
+        <p:nvPicPr>
+          <p:cNvPr id="30" name="Picture 29" descr="globe.png"/>
+          <p:cNvPicPr>
+            <a:picLocks noChangeAspect="1"/>
+          </p:cNvPicPr>
+          <p:nvPr/>
+        </p:nvPicPr>
+        <p:blipFill>
+          <a:blip r:embed="rId18"/>
+          <a:stretch>
+            <a:fillRect/>
+          </a:stretch>
+        </p:blipFill>
+        <p:spPr>
+          <a:xfrm>
+            <a:off x="7729514" y="2743199"/>
+            <a:ext cx="530352" cy="530352"/>
+          </a:xfrm>
+          <a:prstGeom prst="rect">
+            <a:avLst/>
+          </a:prstGeom>
+        </p:spPr>
+      </p:pic>
+      <p:pic>
+        <p:nvPicPr>
+          <p:cNvPr id="31" name="Picture 30" descr="globe.png"/>
+          <p:cNvPicPr>
+            <a:picLocks noChangeAspect="1"/>
+          </p:cNvPicPr>
+          <p:nvPr/>
+        </p:nvPicPr>
+        <p:blipFill>
+          <a:blip r:embed="rId19"/>
+          <a:stretch>
+            <a:fillRect/>
+          </a:stretch>
+        </p:blipFill>
+        <p:spPr>
+          <a:xfrm>
+            <a:off x="8351306" y="2743199"/>
+            <a:ext cx="530352" cy="530352"/>
+          </a:xfrm>
+          <a:prstGeom prst="rect">
+            <a:avLst/>
+          </a:prstGeom>
+        </p:spPr>
+      </p:pic>
+      <p:sp>
+        <p:nvSpPr>
+          <p:cNvPr id="32" name="TextBox 31"/>
+          <p:cNvSpPr txBox="1"/>
+          <p:nvPr/>
+        </p:nvSpPr>
+        <p:spPr>
+          <a:xfrm>
+            <a:off x="7177857" y="3310127"/>
+            <a:ext cx="2255459" cy="274320"/>
+          </a:xfrm>
+          <a:prstGeom prst="rect">
+            <a:avLst/>
+          </a:prstGeom>
+          <a:noFill/>
+        </p:spPr>
+        <p:txBody>
+          <a:bodyPr wrap="square" anchor="t">
+            <a:spAutoFit/>
+          </a:bodyPr>
+          <a:lstStyle/>
+          <a:p>
+            <a:pPr algn="ctr">
+              <a:lnSpc>
+                <a:spcPct val="105000"/>
+              </a:lnSpc>
+              <a:spcAft>
+                <a:spcPts val="600"/>
+              </a:spcAft>
+            </a:pPr>
+            <a:r>
+              <a:rPr sz="800" b="0">
+                <a:solidFill>
+                  <a:srgbClr val="53575A"/>
+                </a:solidFill>
+                <a:latin typeface="Helvetica Neue"/>
+              </a:rPr>
+              <a:t>globe</a:t>
+            </a:r>
+          </a:p>
+        </p:txBody>
+      </p:sp>
+      <p:pic>
+        <p:nvPicPr>
+          <p:cNvPr id="33" name="Picture 32" descr="insight.png"/>
+          <p:cNvPicPr>
+            <a:picLocks noChangeAspect="1"/>
+          </p:cNvPicPr>
+          <p:nvPr/>
+        </p:nvPicPr>
+        <p:blipFill>
+          <a:blip r:embed="rId20"/>
+          <a:stretch>
+            <a:fillRect/>
+          </a:stretch>
+        </p:blipFill>
+        <p:spPr>
+          <a:xfrm>
+            <a:off x="9939253" y="2743199"/>
+            <a:ext cx="530352" cy="530352"/>
+          </a:xfrm>
+          <a:prstGeom prst="rect">
+            <a:avLst/>
+          </a:prstGeom>
+        </p:spPr>
+      </p:pic>
+      <p:pic>
+        <p:nvPicPr>
+          <p:cNvPr id="34" name="Picture 33" descr="insight.png"/>
+          <p:cNvPicPr>
+            <a:picLocks noChangeAspect="1"/>
+          </p:cNvPicPr>
+          <p:nvPr/>
+        </p:nvPicPr>
+        <p:blipFill>
+          <a:blip r:embed="rId21"/>
+          <a:stretch>
+            <a:fillRect/>
+          </a:stretch>
+        </p:blipFill>
+        <p:spPr>
+          <a:xfrm>
+            <a:off x="10561045" y="2743199"/>
+            <a:ext cx="530352" cy="530352"/>
+          </a:xfrm>
+          <a:prstGeom prst="rect">
+            <a:avLst/>
+          </a:prstGeom>
+        </p:spPr>
+      </p:pic>
+      <p:sp>
+        <p:nvSpPr>
+          <p:cNvPr id="35" name="TextBox 34"/>
+          <p:cNvSpPr txBox="1"/>
+          <p:nvPr/>
+        </p:nvSpPr>
+        <p:spPr>
+          <a:xfrm>
+            <a:off x="9387596" y="3310127"/>
+            <a:ext cx="2255459" cy="274320"/>
+          </a:xfrm>
+          <a:prstGeom prst="rect">
+            <a:avLst/>
+          </a:prstGeom>
+          <a:noFill/>
+        </p:spPr>
+        <p:txBody>
+          <a:bodyPr wrap="square" anchor="t">
+            <a:spAutoFit/>
+          </a:bodyPr>
+          <a:lstStyle/>
+          <a:p>
+            <a:pPr algn="ctr">
+              <a:lnSpc>
+                <a:spcPct val="105000"/>
+              </a:lnSpc>
+              <a:spcAft>
+                <a:spcPts val="600"/>
+              </a:spcAft>
+            </a:pPr>
+            <a:r>
+              <a:rPr sz="800" b="0">
+                <a:solidFill>
+                  <a:srgbClr val="53575A"/>
+                </a:solidFill>
+                <a:latin typeface="Helvetica Neue"/>
+              </a:rPr>
+              <a:t>insight</a:t>
+            </a:r>
+          </a:p>
+        </p:txBody>
+      </p:sp>
+      <p:pic>
+        <p:nvPicPr>
+          <p:cNvPr id="36" name="Picture 35" descr="keys.png"/>
+          <p:cNvPicPr>
+            <a:picLocks noChangeAspect="1"/>
+          </p:cNvPicPr>
+          <p:nvPr/>
+        </p:nvPicPr>
+        <p:blipFill>
+          <a:blip r:embed="rId22"/>
+          <a:stretch>
+            <a:fillRect/>
+          </a:stretch>
+        </p:blipFill>
+        <p:spPr>
+          <a:xfrm>
+            <a:off x="1100297" y="3611879"/>
+            <a:ext cx="530352" cy="530352"/>
+          </a:xfrm>
+          <a:prstGeom prst="rect">
+            <a:avLst/>
+          </a:prstGeom>
+        </p:spPr>
+      </p:pic>
+      <p:pic>
+        <p:nvPicPr>
+          <p:cNvPr id="37" name="Picture 36" descr="keys.png"/>
+          <p:cNvPicPr>
+            <a:picLocks noChangeAspect="1"/>
+          </p:cNvPicPr>
+          <p:nvPr/>
+        </p:nvPicPr>
+        <p:blipFill>
+          <a:blip r:embed="rId23"/>
+          <a:stretch>
+            <a:fillRect/>
+          </a:stretch>
+        </p:blipFill>
+        <p:spPr>
+          <a:xfrm>
+            <a:off x="1722089" y="3611879"/>
+            <a:ext cx="530352" cy="530352"/>
+          </a:xfrm>
+          <a:prstGeom prst="rect">
+            <a:avLst/>
+          </a:prstGeom>
+        </p:spPr>
+      </p:pic>
+      <p:sp>
+        <p:nvSpPr>
+          <p:cNvPr id="38" name="TextBox 37"/>
+          <p:cNvSpPr txBox="1"/>
+          <p:nvPr/>
+        </p:nvSpPr>
+        <p:spPr>
+          <a:xfrm>
+            <a:off x="548640" y="4178807"/>
+            <a:ext cx="2255459" cy="274320"/>
+          </a:xfrm>
+          <a:prstGeom prst="rect">
+            <a:avLst/>
+          </a:prstGeom>
+          <a:noFill/>
+        </p:spPr>
+        <p:txBody>
+          <a:bodyPr wrap="square" anchor="t">
+            <a:spAutoFit/>
+          </a:bodyPr>
+          <a:lstStyle/>
+          <a:p>
+            <a:pPr algn="ctr">
+              <a:lnSpc>
+                <a:spcPct val="105000"/>
+              </a:lnSpc>
+              <a:spcAft>
+                <a:spcPts val="600"/>
+              </a:spcAft>
+            </a:pPr>
+            <a:r>
+              <a:rPr sz="800" b="0">
+                <a:solidFill>
+                  <a:srgbClr val="53575A"/>
+                </a:solidFill>
+                <a:latin typeface="Helvetica Neue"/>
+              </a:rPr>
+              <a:t>keys</a:t>
+            </a:r>
+          </a:p>
+        </p:txBody>
+      </p:sp>
+      <p:pic>
+        <p:nvPicPr>
+          <p:cNvPr id="39" name="Picture 38" descr="location.png"/>
+          <p:cNvPicPr>
+            <a:picLocks noChangeAspect="1"/>
+          </p:cNvPicPr>
+          <p:nvPr/>
+        </p:nvPicPr>
+        <p:blipFill>
+          <a:blip r:embed="rId24"/>
+          <a:stretch>
+            <a:fillRect/>
+          </a:stretch>
+        </p:blipFill>
+        <p:spPr>
+          <a:xfrm>
+            <a:off x="3310036" y="3611879"/>
+            <a:ext cx="530352" cy="530352"/>
+          </a:xfrm>
+          <a:prstGeom prst="rect">
+            <a:avLst/>
+          </a:prstGeom>
+        </p:spPr>
+      </p:pic>
+      <p:pic>
+        <p:nvPicPr>
+          <p:cNvPr id="40" name="Picture 39" descr="location.png"/>
+          <p:cNvPicPr>
+            <a:picLocks noChangeAspect="1"/>
+          </p:cNvPicPr>
+          <p:nvPr/>
+        </p:nvPicPr>
+        <p:blipFill>
+          <a:blip r:embed="rId25"/>
+          <a:stretch>
+            <a:fillRect/>
+          </a:stretch>
+        </p:blipFill>
+        <p:spPr>
+          <a:xfrm>
+            <a:off x="3931828" y="3611879"/>
+            <a:ext cx="530352" cy="530352"/>
+          </a:xfrm>
+          <a:prstGeom prst="rect">
+            <a:avLst/>
+          </a:prstGeom>
+        </p:spPr>
+      </p:pic>
+      <p:sp>
+        <p:nvSpPr>
+          <p:cNvPr id="41" name="TextBox 40"/>
+          <p:cNvSpPr txBox="1"/>
+          <p:nvPr/>
+        </p:nvSpPr>
+        <p:spPr>
+          <a:xfrm>
+            <a:off x="2758379" y="4178807"/>
+            <a:ext cx="2255459" cy="274320"/>
+          </a:xfrm>
+          <a:prstGeom prst="rect">
+            <a:avLst/>
+          </a:prstGeom>
+          <a:noFill/>
+        </p:spPr>
+        <p:txBody>
+          <a:bodyPr wrap="square" anchor="t">
+            <a:spAutoFit/>
+          </a:bodyPr>
+          <a:lstStyle/>
+          <a:p>
+            <a:pPr algn="ctr">
+              <a:lnSpc>
+                <a:spcPct val="105000"/>
+              </a:lnSpc>
+              <a:spcAft>
+                <a:spcPts val="600"/>
+              </a:spcAft>
+            </a:pPr>
+            <a:r>
+              <a:rPr sz="800" b="0">
+                <a:solidFill>
+                  <a:srgbClr val="53575A"/>
+                </a:solidFill>
+                <a:latin typeface="Helvetica Neue"/>
+              </a:rPr>
+              <a:t>location</a:t>
+            </a:r>
+          </a:p>
+        </p:txBody>
+      </p:sp>
+      <p:pic>
+        <p:nvPicPr>
+          <p:cNvPr id="42" name="Picture 41" descr="mechanic.png"/>
+          <p:cNvPicPr>
+            <a:picLocks noChangeAspect="1"/>
+          </p:cNvPicPr>
+          <p:nvPr/>
+        </p:nvPicPr>
+        <p:blipFill>
+          <a:blip r:embed="rId26"/>
+          <a:stretch>
+            <a:fillRect/>
+          </a:stretch>
+        </p:blipFill>
+        <p:spPr>
+          <a:xfrm>
+            <a:off x="5519775" y="3611879"/>
+            <a:ext cx="530352" cy="530352"/>
+          </a:xfrm>
+          <a:prstGeom prst="rect">
+            <a:avLst/>
+          </a:prstGeom>
+        </p:spPr>
+      </p:pic>
+      <p:pic>
+        <p:nvPicPr>
+          <p:cNvPr id="43" name="Picture 42" descr="mechanic.png"/>
+          <p:cNvPicPr>
+            <a:picLocks noChangeAspect="1"/>
+          </p:cNvPicPr>
+          <p:nvPr/>
+        </p:nvPicPr>
+        <p:blipFill>
+          <a:blip r:embed="rId27"/>
+          <a:stretch>
+            <a:fillRect/>
+          </a:stretch>
+        </p:blipFill>
+        <p:spPr>
+          <a:xfrm>
+            <a:off x="6141567" y="3611879"/>
+            <a:ext cx="530352" cy="530352"/>
+          </a:xfrm>
+          <a:prstGeom prst="rect">
+            <a:avLst/>
+          </a:prstGeom>
+        </p:spPr>
+      </p:pic>
+      <p:sp>
+        <p:nvSpPr>
+          <p:cNvPr id="44" name="TextBox 43"/>
+          <p:cNvSpPr txBox="1"/>
+          <p:nvPr/>
+        </p:nvSpPr>
+        <p:spPr>
+          <a:xfrm>
+            <a:off x="4968118" y="4178807"/>
+            <a:ext cx="2255459" cy="274320"/>
+          </a:xfrm>
+          <a:prstGeom prst="rect">
+            <a:avLst/>
+          </a:prstGeom>
+          <a:noFill/>
+        </p:spPr>
+        <p:txBody>
+          <a:bodyPr wrap="square" anchor="t">
+            <a:spAutoFit/>
+          </a:bodyPr>
+          <a:lstStyle/>
+          <a:p>
+            <a:pPr algn="ctr">
+              <a:lnSpc>
+                <a:spcPct val="105000"/>
+              </a:lnSpc>
+              <a:spcAft>
+                <a:spcPts val="600"/>
+              </a:spcAft>
+            </a:pPr>
+            <a:r>
+              <a:rPr sz="800" b="0">
+                <a:solidFill>
+                  <a:srgbClr val="53575A"/>
+                </a:solidFill>
+                <a:latin typeface="Helvetica Neue"/>
+              </a:rPr>
+              <a:t>mechanic</a:t>
+            </a:r>
+          </a:p>
+        </p:txBody>
+      </p:sp>
+      <p:pic>
+        <p:nvPicPr>
+          <p:cNvPr id="45" name="Picture 44" descr="money.png"/>
+          <p:cNvPicPr>
+            <a:picLocks noChangeAspect="1"/>
+          </p:cNvPicPr>
+          <p:nvPr/>
+        </p:nvPicPr>
+        <p:blipFill>
+          <a:blip r:embed="rId28"/>
+          <a:stretch>
+            <a:fillRect/>
+          </a:stretch>
+        </p:blipFill>
+        <p:spPr>
+          <a:xfrm>
+            <a:off x="7729514" y="3611879"/>
+            <a:ext cx="530352" cy="530352"/>
+          </a:xfrm>
+          <a:prstGeom prst="rect">
+            <a:avLst/>
+          </a:prstGeom>
+        </p:spPr>
+      </p:pic>
+      <p:pic>
+        <p:nvPicPr>
+          <p:cNvPr id="46" name="Picture 45" descr="money.png"/>
+          <p:cNvPicPr>
+            <a:picLocks noChangeAspect="1"/>
+          </p:cNvPicPr>
+          <p:nvPr/>
+        </p:nvPicPr>
+        <p:blipFill>
+          <a:blip r:embed="rId29"/>
+          <a:stretch>
+            <a:fillRect/>
+          </a:stretch>
+        </p:blipFill>
+        <p:spPr>
+          <a:xfrm>
+            <a:off x="8351306" y="3611879"/>
+            <a:ext cx="530352" cy="530352"/>
+          </a:xfrm>
+          <a:prstGeom prst="rect">
+            <a:avLst/>
+          </a:prstGeom>
+        </p:spPr>
+      </p:pic>
+      <p:sp>
+        <p:nvSpPr>
+          <p:cNvPr id="47" name="TextBox 46"/>
+          <p:cNvSpPr txBox="1"/>
+          <p:nvPr/>
+        </p:nvSpPr>
+        <p:spPr>
+          <a:xfrm>
+            <a:off x="7177857" y="4178807"/>
+            <a:ext cx="2255459" cy="274320"/>
+          </a:xfrm>
+          <a:prstGeom prst="rect">
+            <a:avLst/>
+          </a:prstGeom>
+          <a:noFill/>
+        </p:spPr>
+        <p:txBody>
+          <a:bodyPr wrap="square" anchor="t">
+            <a:spAutoFit/>
+          </a:bodyPr>
+          <a:lstStyle/>
+          <a:p>
+            <a:pPr algn="ctr">
+              <a:lnSpc>
+                <a:spcPct val="105000"/>
+              </a:lnSpc>
+              <a:spcAft>
+                <a:spcPts val="600"/>
+              </a:spcAft>
+            </a:pPr>
+            <a:r>
+              <a:rPr sz="800" b="0">
+                <a:solidFill>
+                  <a:srgbClr val="53575A"/>
+                </a:solidFill>
+                <a:latin typeface="Helvetica Neue"/>
+              </a:rPr>
+              <a:t>money</a:t>
+            </a:r>
+          </a:p>
+        </p:txBody>
+      </p:sp>
+      <p:pic>
+        <p:nvPicPr>
+          <p:cNvPr id="48" name="Picture 47" descr="peak.png"/>
+          <p:cNvPicPr>
+            <a:picLocks noChangeAspect="1"/>
+          </p:cNvPicPr>
+          <p:nvPr/>
+        </p:nvPicPr>
+        <p:blipFill>
+          <a:blip r:embed="rId30"/>
+          <a:stretch>
+            <a:fillRect/>
+          </a:stretch>
+        </p:blipFill>
+        <p:spPr>
+          <a:xfrm>
+            <a:off x="9939253" y="3611879"/>
+            <a:ext cx="530352" cy="530352"/>
+          </a:xfrm>
+          <a:prstGeom prst="rect">
+            <a:avLst/>
+          </a:prstGeom>
+        </p:spPr>
+      </p:pic>
+      <p:pic>
+        <p:nvPicPr>
+          <p:cNvPr id="49" name="Picture 48" descr="peak.png"/>
+          <p:cNvPicPr>
+            <a:picLocks noChangeAspect="1"/>
+          </p:cNvPicPr>
+          <p:nvPr/>
+        </p:nvPicPr>
+        <p:blipFill>
+          <a:blip r:embed="rId31"/>
+          <a:stretch>
+            <a:fillRect/>
+          </a:stretch>
+        </p:blipFill>
+        <p:spPr>
+          <a:xfrm>
+            <a:off x="10561045" y="3611879"/>
+            <a:ext cx="530352" cy="530352"/>
+          </a:xfrm>
+          <a:prstGeom prst="rect">
+            <a:avLst/>
+          </a:prstGeom>
+        </p:spPr>
+      </p:pic>
+      <p:sp>
+        <p:nvSpPr>
+          <p:cNvPr id="50" name="TextBox 49"/>
+          <p:cNvSpPr txBox="1"/>
+          <p:nvPr/>
+        </p:nvSpPr>
+        <p:spPr>
+          <a:xfrm>
+            <a:off x="9387596" y="4178807"/>
+            <a:ext cx="2255459" cy="274320"/>
+          </a:xfrm>
+          <a:prstGeom prst="rect">
+            <a:avLst/>
+          </a:prstGeom>
+          <a:noFill/>
+        </p:spPr>
+        <p:txBody>
+          <a:bodyPr wrap="square" anchor="t">
+            <a:spAutoFit/>
+          </a:bodyPr>
+          <a:lstStyle/>
+          <a:p>
+            <a:pPr algn="ctr">
+              <a:lnSpc>
+                <a:spcPct val="105000"/>
+              </a:lnSpc>
+              <a:spcAft>
+                <a:spcPts val="600"/>
+              </a:spcAft>
+            </a:pPr>
+            <a:r>
+              <a:rPr sz="800" b="0">
+                <a:solidFill>
+                  <a:srgbClr val="53575A"/>
+                </a:solidFill>
+                <a:latin typeface="Helvetica Neue"/>
+              </a:rPr>
+              <a:t>peak</a:t>
+            </a:r>
+          </a:p>
+        </p:txBody>
+      </p:sp>
+      <p:pic>
+        <p:nvPicPr>
+          <p:cNvPr id="51" name="Picture 50" descr="people.png"/>
+          <p:cNvPicPr>
+            <a:picLocks noChangeAspect="1"/>
+          </p:cNvPicPr>
+          <p:nvPr/>
+        </p:nvPicPr>
+        <p:blipFill>
+          <a:blip r:embed="rId32"/>
+          <a:stretch>
+            <a:fillRect/>
+          </a:stretch>
+        </p:blipFill>
+        <p:spPr>
+          <a:xfrm>
+            <a:off x="1100297" y="4480559"/>
+            <a:ext cx="530352" cy="530352"/>
+          </a:xfrm>
+          <a:prstGeom prst="rect">
+            <a:avLst/>
+          </a:prstGeom>
+        </p:spPr>
+      </p:pic>
+      <p:pic>
+        <p:nvPicPr>
+          <p:cNvPr id="52" name="Picture 51" descr="people.png"/>
+          <p:cNvPicPr>
+            <a:picLocks noChangeAspect="1"/>
+          </p:cNvPicPr>
+          <p:nvPr/>
+        </p:nvPicPr>
+        <p:blipFill>
+          <a:blip r:embed="rId33"/>
+          <a:stretch>
+            <a:fillRect/>
+          </a:stretch>
+        </p:blipFill>
+        <p:spPr>
+          <a:xfrm>
+            <a:off x="1722089" y="4480559"/>
+            <a:ext cx="530352" cy="530352"/>
+          </a:xfrm>
+          <a:prstGeom prst="rect">
+            <a:avLst/>
+          </a:prstGeom>
+        </p:spPr>
+      </p:pic>
+      <p:sp>
+        <p:nvSpPr>
+          <p:cNvPr id="53" name="TextBox 52"/>
+          <p:cNvSpPr txBox="1"/>
+          <p:nvPr/>
+        </p:nvSpPr>
+        <p:spPr>
+          <a:xfrm>
+            <a:off x="548640" y="5047487"/>
+            <a:ext cx="2255459" cy="274320"/>
+          </a:xfrm>
+          <a:prstGeom prst="rect">
+            <a:avLst/>
+          </a:prstGeom>
+          <a:noFill/>
+        </p:spPr>
+        <p:txBody>
+          <a:bodyPr wrap="square" anchor="t">
+            <a:spAutoFit/>
+          </a:bodyPr>
+          <a:lstStyle/>
+          <a:p>
+            <a:pPr algn="ctr">
+              <a:lnSpc>
+                <a:spcPct val="105000"/>
+              </a:lnSpc>
+              <a:spcAft>
+                <a:spcPts val="600"/>
+              </a:spcAft>
+            </a:pPr>
+            <a:r>
+              <a:rPr sz="800" b="0">
+                <a:solidFill>
+                  <a:srgbClr val="53575A"/>
+                </a:solidFill>
+                <a:latin typeface="Helvetica Neue"/>
+              </a:rPr>
+              <a:t>people</a:t>
+            </a:r>
+          </a:p>
+        </p:txBody>
+      </p:sp>
+      <p:pic>
+        <p:nvPicPr>
+          <p:cNvPr id="54" name="Picture 53" descr="presenter.png"/>
+          <p:cNvPicPr>
+            <a:picLocks noChangeAspect="1"/>
+          </p:cNvPicPr>
+          <p:nvPr/>
+        </p:nvPicPr>
+        <p:blipFill>
+          <a:blip r:embed="rId34"/>
+          <a:stretch>
+            <a:fillRect/>
+          </a:stretch>
+        </p:blipFill>
+        <p:spPr>
+          <a:xfrm>
+            <a:off x="3310036" y="4480559"/>
+            <a:ext cx="530352" cy="530352"/>
+          </a:xfrm>
+          <a:prstGeom prst="rect">
+            <a:avLst/>
+          </a:prstGeom>
+        </p:spPr>
+      </p:pic>
+      <p:pic>
+        <p:nvPicPr>
+          <p:cNvPr id="55" name="Picture 54" descr="presenter.png"/>
+          <p:cNvPicPr>
+            <a:picLocks noChangeAspect="1"/>
+          </p:cNvPicPr>
+          <p:nvPr/>
+        </p:nvPicPr>
+        <p:blipFill>
+          <a:blip r:embed="rId35"/>
+          <a:stretch>
+            <a:fillRect/>
+          </a:stretch>
+        </p:blipFill>
+        <p:spPr>
+          <a:xfrm>
+            <a:off x="3931828" y="4480559"/>
+            <a:ext cx="530352" cy="530352"/>
+          </a:xfrm>
+          <a:prstGeom prst="rect">
+            <a:avLst/>
+          </a:prstGeom>
+        </p:spPr>
+      </p:pic>
+      <p:sp>
+        <p:nvSpPr>
+          <p:cNvPr id="56" name="TextBox 55"/>
+          <p:cNvSpPr txBox="1"/>
+          <p:nvPr/>
+        </p:nvSpPr>
+        <p:spPr>
+          <a:xfrm>
+            <a:off x="2758379" y="5047487"/>
+            <a:ext cx="2255459" cy="274320"/>
+          </a:xfrm>
+          <a:prstGeom prst="rect">
+            <a:avLst/>
+          </a:prstGeom>
+          <a:noFill/>
+        </p:spPr>
+        <p:txBody>
+          <a:bodyPr wrap="square" anchor="t">
+            <a:spAutoFit/>
+          </a:bodyPr>
+          <a:lstStyle/>
+          <a:p>
+            <a:pPr algn="ctr">
+              <a:lnSpc>
+                <a:spcPct val="105000"/>
+              </a:lnSpc>
+              <a:spcAft>
+                <a:spcPts val="600"/>
+              </a:spcAft>
+            </a:pPr>
+            <a:r>
+              <a:rPr sz="800" b="0">
+                <a:solidFill>
+                  <a:srgbClr val="53575A"/>
+                </a:solidFill>
+                <a:latin typeface="Helvetica Neue"/>
+              </a:rPr>
+              <a:t>presenter</a:t>
+            </a:r>
+          </a:p>
+        </p:txBody>
+      </p:sp>
+      <p:pic>
+        <p:nvPicPr>
+          <p:cNvPr id="57" name="Picture 56" descr="star.png"/>
+          <p:cNvPicPr>
+            <a:picLocks noChangeAspect="1"/>
+          </p:cNvPicPr>
+          <p:nvPr/>
+        </p:nvPicPr>
+        <p:blipFill>
+          <a:blip r:embed="rId36"/>
+          <a:stretch>
+            <a:fillRect/>
+          </a:stretch>
+        </p:blipFill>
+        <p:spPr>
+          <a:xfrm>
+            <a:off x="5519775" y="4480559"/>
+            <a:ext cx="530352" cy="530352"/>
+          </a:xfrm>
+          <a:prstGeom prst="rect">
+            <a:avLst/>
+          </a:prstGeom>
+        </p:spPr>
+      </p:pic>
+      <p:pic>
+        <p:nvPicPr>
+          <p:cNvPr id="58" name="Picture 57" descr="star.png"/>
+          <p:cNvPicPr>
+            <a:picLocks noChangeAspect="1"/>
+          </p:cNvPicPr>
+          <p:nvPr/>
+        </p:nvPicPr>
+        <p:blipFill>
+          <a:blip r:embed="rId37"/>
+          <a:stretch>
+            <a:fillRect/>
+          </a:stretch>
+        </p:blipFill>
+        <p:spPr>
+          <a:xfrm>
+            <a:off x="6141567" y="4480559"/>
+            <a:ext cx="530352" cy="530352"/>
+          </a:xfrm>
+          <a:prstGeom prst="rect">
+            <a:avLst/>
+          </a:prstGeom>
+        </p:spPr>
+      </p:pic>
+      <p:sp>
+        <p:nvSpPr>
+          <p:cNvPr id="59" name="TextBox 58"/>
+          <p:cNvSpPr txBox="1"/>
+          <p:nvPr/>
+        </p:nvSpPr>
+        <p:spPr>
+          <a:xfrm>
+            <a:off x="4968118" y="5047487"/>
+            <a:ext cx="2255459" cy="274320"/>
+          </a:xfrm>
+          <a:prstGeom prst="rect">
+            <a:avLst/>
+          </a:prstGeom>
+          <a:noFill/>
+        </p:spPr>
+        <p:txBody>
+          <a:bodyPr wrap="square" anchor="t">
+            <a:spAutoFit/>
+          </a:bodyPr>
+          <a:lstStyle/>
+          <a:p>
+            <a:pPr algn="ctr">
+              <a:lnSpc>
+                <a:spcPct val="105000"/>
+              </a:lnSpc>
+              <a:spcAft>
+                <a:spcPts val="600"/>
+              </a:spcAft>
+            </a:pPr>
+            <a:r>
+              <a:rPr sz="800" b="0">
+                <a:solidFill>
+                  <a:srgbClr val="53575A"/>
+                </a:solidFill>
+                <a:latin typeface="Helvetica Neue"/>
+              </a:rPr>
+              <a:t>star</a:t>
+            </a:r>
+          </a:p>
+        </p:txBody>
+      </p:sp>
+      <p:pic>
+        <p:nvPicPr>
+          <p:cNvPr id="60" name="Picture 59" descr="swoosh.png"/>
+          <p:cNvPicPr>
+            <a:picLocks noChangeAspect="1"/>
+          </p:cNvPicPr>
+          <p:nvPr/>
+        </p:nvPicPr>
+        <p:blipFill>
+          <a:blip r:embed="rId38"/>
+          <a:stretch>
+            <a:fillRect/>
+          </a:stretch>
+        </p:blipFill>
+        <p:spPr>
+          <a:xfrm>
+            <a:off x="7729514" y="4480559"/>
+            <a:ext cx="530352" cy="530352"/>
+          </a:xfrm>
+          <a:prstGeom prst="rect">
+            <a:avLst/>
+          </a:prstGeom>
+        </p:spPr>
+      </p:pic>
+      <p:pic>
+        <p:nvPicPr>
+          <p:cNvPr id="61" name="Picture 60" descr="swoosh.png"/>
+          <p:cNvPicPr>
+            <a:picLocks noChangeAspect="1"/>
+          </p:cNvPicPr>
+          <p:nvPr/>
+        </p:nvPicPr>
+        <p:blipFill>
+          <a:blip r:embed="rId39"/>
+          <a:stretch>
+            <a:fillRect/>
+          </a:stretch>
+        </p:blipFill>
+        <p:spPr>
+          <a:xfrm>
+            <a:off x="8351306" y="4480559"/>
+            <a:ext cx="530352" cy="530352"/>
+          </a:xfrm>
+          <a:prstGeom prst="rect">
+            <a:avLst/>
+          </a:prstGeom>
+        </p:spPr>
+      </p:pic>
+      <p:sp>
+        <p:nvSpPr>
+          <p:cNvPr id="62" name="TextBox 61"/>
+          <p:cNvSpPr txBox="1"/>
+          <p:nvPr/>
+        </p:nvSpPr>
+        <p:spPr>
+          <a:xfrm>
+            <a:off x="7177857" y="5047487"/>
+            <a:ext cx="2255459" cy="274320"/>
+          </a:xfrm>
+          <a:prstGeom prst="rect">
+            <a:avLst/>
+          </a:prstGeom>
+          <a:noFill/>
+        </p:spPr>
+        <p:txBody>
+          <a:bodyPr wrap="square" anchor="t">
+            <a:spAutoFit/>
+          </a:bodyPr>
+          <a:lstStyle/>
+          <a:p>
+            <a:pPr algn="ctr">
+              <a:lnSpc>
+                <a:spcPct val="105000"/>
+              </a:lnSpc>
+              <a:spcAft>
+                <a:spcPts val="600"/>
+              </a:spcAft>
+            </a:pPr>
+            <a:r>
+              <a:rPr sz="800" b="0">
+                <a:solidFill>
+                  <a:srgbClr val="53575A"/>
+                </a:solidFill>
+                <a:latin typeface="Helvetica Neue"/>
+              </a:rPr>
+              <a:t>swoosh</a:t>
+            </a:r>
+          </a:p>
+        </p:txBody>
+      </p:sp>
+      <p:pic>
+        <p:nvPicPr>
+          <p:cNvPr id="63" name="Picture 62" descr="target.png"/>
+          <p:cNvPicPr>
+            <a:picLocks noChangeAspect="1"/>
+          </p:cNvPicPr>
+          <p:nvPr/>
+        </p:nvPicPr>
+        <p:blipFill>
+          <a:blip r:embed="rId40"/>
+          <a:stretch>
+            <a:fillRect/>
+          </a:stretch>
+        </p:blipFill>
+        <p:spPr>
+          <a:xfrm>
+            <a:off x="9939253" y="4480559"/>
+            <a:ext cx="530352" cy="530352"/>
+          </a:xfrm>
+          <a:prstGeom prst="rect">
+            <a:avLst/>
+          </a:prstGeom>
+        </p:spPr>
+      </p:pic>
+      <p:pic>
+        <p:nvPicPr>
+          <p:cNvPr id="64" name="Picture 63" descr="target.png"/>
+          <p:cNvPicPr>
+            <a:picLocks noChangeAspect="1"/>
+          </p:cNvPicPr>
+          <p:nvPr/>
+        </p:nvPicPr>
+        <p:blipFill>
+          <a:blip r:embed="rId41"/>
+          <a:stretch>
+            <a:fillRect/>
+          </a:stretch>
+        </p:blipFill>
+        <p:spPr>
+          <a:xfrm>
+            <a:off x="10561045" y="4480559"/>
+            <a:ext cx="530352" cy="530352"/>
+          </a:xfrm>
+          <a:prstGeom prst="rect">
+            <a:avLst/>
+          </a:prstGeom>
+        </p:spPr>
+      </p:pic>
+      <p:sp>
+        <p:nvSpPr>
+          <p:cNvPr id="65" name="TextBox 64"/>
+          <p:cNvSpPr txBox="1"/>
+          <p:nvPr/>
+        </p:nvSpPr>
+        <p:spPr>
+          <a:xfrm>
+            <a:off x="9387596" y="5047487"/>
+            <a:ext cx="2255459" cy="274320"/>
+          </a:xfrm>
+          <a:prstGeom prst="rect">
+            <a:avLst/>
+          </a:prstGeom>
+          <a:noFill/>
+        </p:spPr>
+        <p:txBody>
+          <a:bodyPr wrap="square" anchor="t">
+            <a:spAutoFit/>
+          </a:bodyPr>
+          <a:lstStyle/>
+          <a:p>
+            <a:pPr algn="ctr">
+              <a:lnSpc>
+                <a:spcPct val="105000"/>
+              </a:lnSpc>
+              <a:spcAft>
+                <a:spcPts val="600"/>
+              </a:spcAft>
+            </a:pPr>
+            <a:r>
+              <a:rPr sz="800" b="0">
+                <a:solidFill>
+                  <a:srgbClr val="53575A"/>
+                </a:solidFill>
+                <a:latin typeface="Helvetica Neue"/>
+              </a:rPr>
+              <a:t>target</a:t>
+            </a:r>
+          </a:p>
+        </p:txBody>
+      </p:sp>
+      <p:pic>
+        <p:nvPicPr>
+          <p:cNvPr id="66" name="Picture 65" descr="top-performer.png"/>
+          <p:cNvPicPr>
+            <a:picLocks noChangeAspect="1"/>
+          </p:cNvPicPr>
+          <p:nvPr/>
+        </p:nvPicPr>
+        <p:blipFill>
+          <a:blip r:embed="rId42"/>
+          <a:stretch>
+            <a:fillRect/>
+          </a:stretch>
+        </p:blipFill>
+        <p:spPr>
+          <a:xfrm>
+            <a:off x="1100297" y="5349239"/>
+            <a:ext cx="530352" cy="530352"/>
+          </a:xfrm>
+          <a:prstGeom prst="rect">
+            <a:avLst/>
+          </a:prstGeom>
+        </p:spPr>
+      </p:pic>
+      <p:pic>
+        <p:nvPicPr>
+          <p:cNvPr id="67" name="Picture 66" descr="top-performer.png"/>
+          <p:cNvPicPr>
+            <a:picLocks noChangeAspect="1"/>
+          </p:cNvPicPr>
+          <p:nvPr/>
+        </p:nvPicPr>
+        <p:blipFill>
+          <a:blip r:embed="rId43"/>
+          <a:stretch>
+            <a:fillRect/>
+          </a:stretch>
+        </p:blipFill>
+        <p:spPr>
+          <a:xfrm>
+            <a:off x="1722089" y="5349239"/>
+            <a:ext cx="530352" cy="530352"/>
+          </a:xfrm>
+          <a:prstGeom prst="rect">
+            <a:avLst/>
+          </a:prstGeom>
+        </p:spPr>
+      </p:pic>
+      <p:sp>
+        <p:nvSpPr>
+          <p:cNvPr id="68" name="TextBox 67"/>
+          <p:cNvSpPr txBox="1"/>
+          <p:nvPr/>
+        </p:nvSpPr>
+        <p:spPr>
+          <a:xfrm>
+            <a:off x="548640" y="5916167"/>
+            <a:ext cx="2255459" cy="274320"/>
+          </a:xfrm>
+          <a:prstGeom prst="rect">
+            <a:avLst/>
+          </a:prstGeom>
+          <a:noFill/>
+        </p:spPr>
+        <p:txBody>
+          <a:bodyPr wrap="square" anchor="t">
+            <a:spAutoFit/>
+          </a:bodyPr>
+          <a:lstStyle/>
+          <a:p>
+            <a:pPr algn="ctr">
+              <a:lnSpc>
+                <a:spcPct val="105000"/>
+              </a:lnSpc>
+              <a:spcAft>
+                <a:spcPts val="600"/>
+              </a:spcAft>
+            </a:pPr>
+            <a:r>
+              <a:rPr sz="800" b="0">
+                <a:solidFill>
+                  <a:srgbClr val="53575A"/>
+                </a:solidFill>
+                <a:latin typeface="Helvetica Neue"/>
+              </a:rPr>
+              <a:t>top-performer</a:t>
+            </a:r>
+          </a:p>
+        </p:txBody>
+      </p:sp>
+      <p:pic>
+        <p:nvPicPr>
+          <p:cNvPr id="69" name="Picture 68" descr="truck.png"/>
+          <p:cNvPicPr>
+            <a:picLocks noChangeAspect="1"/>
+          </p:cNvPicPr>
+          <p:nvPr/>
+        </p:nvPicPr>
+        <p:blipFill>
+          <a:blip r:embed="rId44"/>
+          <a:stretch>
+            <a:fillRect/>
+          </a:stretch>
+        </p:blipFill>
+        <p:spPr>
+          <a:xfrm>
+            <a:off x="3310036" y="5349239"/>
+            <a:ext cx="530352" cy="530352"/>
+          </a:xfrm>
+          <a:prstGeom prst="rect">
+            <a:avLst/>
+          </a:prstGeom>
+        </p:spPr>
+      </p:pic>
+      <p:pic>
+        <p:nvPicPr>
+          <p:cNvPr id="70" name="Picture 69" descr="truck.png"/>
+          <p:cNvPicPr>
+            <a:picLocks noChangeAspect="1"/>
+          </p:cNvPicPr>
+          <p:nvPr/>
+        </p:nvPicPr>
+        <p:blipFill>
+          <a:blip r:embed="rId45"/>
+          <a:stretch>
+            <a:fillRect/>
+          </a:stretch>
+        </p:blipFill>
+        <p:spPr>
+          <a:xfrm>
+            <a:off x="3931828" y="5349239"/>
+            <a:ext cx="530352" cy="530352"/>
+          </a:xfrm>
+          <a:prstGeom prst="rect">
+            <a:avLst/>
+          </a:prstGeom>
+        </p:spPr>
+      </p:pic>
+      <p:sp>
+        <p:nvSpPr>
+          <p:cNvPr id="71" name="TextBox 70"/>
+          <p:cNvSpPr txBox="1"/>
+          <p:nvPr/>
+        </p:nvSpPr>
+        <p:spPr>
+          <a:xfrm>
+            <a:off x="2758379" y="5916167"/>
+            <a:ext cx="2255459" cy="274320"/>
+          </a:xfrm>
+          <a:prstGeom prst="rect">
+            <a:avLst/>
+          </a:prstGeom>
+          <a:noFill/>
+        </p:spPr>
+        <p:txBody>
+          <a:bodyPr wrap="square" anchor="t">
+            <a:spAutoFit/>
+          </a:bodyPr>
+          <a:lstStyle/>
+          <a:p>
+            <a:pPr algn="ctr">
+              <a:lnSpc>
+                <a:spcPct val="105000"/>
+              </a:lnSpc>
+              <a:spcAft>
+                <a:spcPts val="600"/>
+              </a:spcAft>
+            </a:pPr>
+            <a:r>
+              <a:rPr sz="800" b="0">
+                <a:solidFill>
+                  <a:srgbClr val="53575A"/>
+                </a:solidFill>
+                <a:latin typeface="Helvetica Neue"/>
+              </a:rPr>
+              <a:t>truck</a:t>
+            </a:r>
+          </a:p>
+        </p:txBody>
+      </p:sp>
+      <p:pic>
+        <p:nvPicPr>
+          <p:cNvPr id="72" name="Picture 71" descr="user.png"/>
+          <p:cNvPicPr>
+            <a:picLocks noChangeAspect="1"/>
+          </p:cNvPicPr>
+          <p:nvPr/>
+        </p:nvPicPr>
+        <p:blipFill>
+          <a:blip r:embed="rId46"/>
+          <a:stretch>
+            <a:fillRect/>
+          </a:stretch>
+        </p:blipFill>
+        <p:spPr>
+          <a:xfrm>
+            <a:off x="5519775" y="5349239"/>
+            <a:ext cx="530352" cy="530352"/>
+          </a:xfrm>
+          <a:prstGeom prst="rect">
+            <a:avLst/>
+          </a:prstGeom>
+        </p:spPr>
+      </p:pic>
+      <p:pic>
+        <p:nvPicPr>
+          <p:cNvPr id="73" name="Picture 72" descr="user.png"/>
+          <p:cNvPicPr>
+            <a:picLocks noChangeAspect="1"/>
+          </p:cNvPicPr>
+          <p:nvPr/>
+        </p:nvPicPr>
+        <p:blipFill>
+          <a:blip r:embed="rId47"/>
+          <a:stretch>
+            <a:fillRect/>
+          </a:stretch>
+        </p:blipFill>
+        <p:spPr>
+          <a:xfrm>
+            <a:off x="6141567" y="5349239"/>
+            <a:ext cx="530352" cy="530352"/>
+          </a:xfrm>
+          <a:prstGeom prst="rect">
+            <a:avLst/>
+          </a:prstGeom>
+        </p:spPr>
+      </p:pic>
+      <p:sp>
+        <p:nvSpPr>
+          <p:cNvPr id="74" name="TextBox 73"/>
+          <p:cNvSpPr txBox="1"/>
+          <p:nvPr/>
+        </p:nvSpPr>
+        <p:spPr>
+          <a:xfrm>
+            <a:off x="4968118" y="5916167"/>
+            <a:ext cx="2255459" cy="274320"/>
+          </a:xfrm>
+          <a:prstGeom prst="rect">
+            <a:avLst/>
+          </a:prstGeom>
+          <a:noFill/>
+        </p:spPr>
+        <p:txBody>
+          <a:bodyPr wrap="square" anchor="t">
+            <a:spAutoFit/>
+          </a:bodyPr>
+          <a:lstStyle/>
+          <a:p>
+            <a:pPr algn="ctr">
+              <a:lnSpc>
+                <a:spcPct val="105000"/>
+              </a:lnSpc>
+              <a:spcAft>
+                <a:spcPts val="600"/>
+              </a:spcAft>
+            </a:pPr>
+            <a:r>
+              <a:rPr sz="800" b="0">
+                <a:solidFill>
+                  <a:srgbClr val="53575A"/>
+                </a:solidFill>
+                <a:latin typeface="Helvetica Neue"/>
+              </a:rPr>
+              <a:t>user</a:t>
+            </a:r>
+          </a:p>
+        </p:txBody>
+      </p:sp>
+      <p:pic>
+        <p:nvPicPr>
+          <p:cNvPr id="75" name="Picture 74" descr="video.png"/>
+          <p:cNvPicPr>
+            <a:picLocks noChangeAspect="1"/>
+          </p:cNvPicPr>
+          <p:nvPr/>
+        </p:nvPicPr>
+        <p:blipFill>
+          <a:blip r:embed="rId48"/>
+          <a:stretch>
+            <a:fillRect/>
+          </a:stretch>
+        </p:blipFill>
+        <p:spPr>
+          <a:xfrm>
+            <a:off x="7729514" y="5349239"/>
+            <a:ext cx="530352" cy="530352"/>
+          </a:xfrm>
+          <a:prstGeom prst="rect">
+            <a:avLst/>
+          </a:prstGeom>
+        </p:spPr>
+      </p:pic>
+      <p:pic>
+        <p:nvPicPr>
+          <p:cNvPr id="76" name="Picture 75" descr="video.png"/>
+          <p:cNvPicPr>
+            <a:picLocks noChangeAspect="1"/>
+          </p:cNvPicPr>
+          <p:nvPr/>
+        </p:nvPicPr>
+        <p:blipFill>
+          <a:blip r:embed="rId49"/>
+          <a:stretch>
+            <a:fillRect/>
+          </a:stretch>
+        </p:blipFill>
+        <p:spPr>
+          <a:xfrm>
+            <a:off x="8351306" y="5349239"/>
+            <a:ext cx="530352" cy="530352"/>
+          </a:xfrm>
+          <a:prstGeom prst="rect">
+            <a:avLst/>
+          </a:prstGeom>
+        </p:spPr>
+      </p:pic>
+      <p:sp>
+        <p:nvSpPr>
+          <p:cNvPr id="77" name="TextBox 76"/>
+          <p:cNvSpPr txBox="1"/>
+          <p:nvPr/>
+        </p:nvSpPr>
+        <p:spPr>
+          <a:xfrm>
+            <a:off x="7177857" y="5916167"/>
+            <a:ext cx="2255459" cy="274320"/>
+          </a:xfrm>
+          <a:prstGeom prst="rect">
+            <a:avLst/>
+          </a:prstGeom>
+          <a:noFill/>
+        </p:spPr>
+        <p:txBody>
+          <a:bodyPr wrap="square" anchor="t">
+            <a:spAutoFit/>
+          </a:bodyPr>
+          <a:lstStyle/>
+          <a:p>
+            <a:pPr algn="ctr">
+              <a:lnSpc>
+                <a:spcPct val="105000"/>
+              </a:lnSpc>
+              <a:spcAft>
+                <a:spcPts val="600"/>
+              </a:spcAft>
+            </a:pPr>
+            <a:r>
+              <a:rPr sz="800" b="0">
+                <a:solidFill>
+                  <a:srgbClr val="53575A"/>
+                </a:solidFill>
+                <a:latin typeface="Helvetica Neue"/>
+              </a:rPr>
+              <a:t>video</a:t>
+            </a:r>
+          </a:p>
+        </p:txBody>
+      </p:sp>
+      <p:pic>
+        <p:nvPicPr>
+          <p:cNvPr id="78" name="Picture 77" descr="wrench.png"/>
+          <p:cNvPicPr>
+            <a:picLocks noChangeAspect="1"/>
+          </p:cNvPicPr>
+          <p:nvPr/>
+        </p:nvPicPr>
+        <p:blipFill>
+          <a:blip r:embed="rId50"/>
+          <a:stretch>
+            <a:fillRect/>
+          </a:stretch>
+        </p:blipFill>
+        <p:spPr>
+          <a:xfrm>
+            <a:off x="9939253" y="5349239"/>
+            <a:ext cx="530352" cy="530352"/>
+          </a:xfrm>
+          <a:prstGeom prst="rect">
+            <a:avLst/>
+          </a:prstGeom>
+        </p:spPr>
+      </p:pic>
+      <p:pic>
+        <p:nvPicPr>
+          <p:cNvPr id="79" name="Picture 78" descr="wrench.png"/>
+          <p:cNvPicPr>
+            <a:picLocks noChangeAspect="1"/>
+          </p:cNvPicPr>
+          <p:nvPr/>
+        </p:nvPicPr>
+        <p:blipFill>
+          <a:blip r:embed="rId51"/>
+          <a:stretch>
+            <a:fillRect/>
+          </a:stretch>
+        </p:blipFill>
+        <p:spPr>
+          <a:xfrm>
+            <a:off x="10561045" y="5349239"/>
+            <a:ext cx="530352" cy="530352"/>
+          </a:xfrm>
+          <a:prstGeom prst="rect">
+            <a:avLst/>
+          </a:prstGeom>
+        </p:spPr>
+      </p:pic>
+      <p:sp>
+        <p:nvSpPr>
+          <p:cNvPr id="80" name="TextBox 79"/>
+          <p:cNvSpPr txBox="1"/>
+          <p:nvPr/>
+        </p:nvSpPr>
+        <p:spPr>
+          <a:xfrm>
+            <a:off x="9387596" y="5916167"/>
+            <a:ext cx="2255459" cy="274320"/>
+          </a:xfrm>
+          <a:prstGeom prst="rect">
+            <a:avLst/>
+          </a:prstGeom>
+          <a:noFill/>
+        </p:spPr>
+        <p:txBody>
+          <a:bodyPr wrap="square" anchor="t">
+            <a:spAutoFit/>
+          </a:bodyPr>
+          <a:lstStyle/>
+          <a:p>
+            <a:pPr algn="ctr">
+              <a:lnSpc>
+                <a:spcPct val="105000"/>
+              </a:lnSpc>
+              <a:spcAft>
+                <a:spcPts val="600"/>
+              </a:spcAft>
+            </a:pPr>
+            <a:r>
+              <a:rPr sz="800" b="0">
+                <a:solidFill>
+                  <a:srgbClr val="53575A"/>
+                </a:solidFill>
+                <a:latin typeface="Helvetica Neue"/>
+              </a:rPr>
+              <a:t>wrench</a:t>
+            </a:r>
+          </a:p>
+        </p:txBody>
+      </p:sp>
+    </p:spTree>
+  </p:cSld>
+  <p:clrMapOvr>
+    <a:masterClrMapping/>
+  </p:clrMapOvr>
+  <p:transition spd="med">
+    <p:fade/>
+  </p:transition>
+</p:sld>
+</file>
+
+<file path=ppt/slides/slide27.xml><?xml version="1.0" encoding="utf-8"?>
 <p:sld xmlns:a="http://schemas.openxmlformats.org/drawingml/2006/main" xmlns:p="http://schemas.openxmlformats.org/presentationml/2006/main" xmlns:r="http://schemas.openxmlformats.org/officeDocument/2006/relationships">
   <p:cSld>
     <p:spTree>

</xml_diff>

<commit_message>
Improve Build Slides step/process slide
</commit_message>
<xml_diff>
--- a/Peach State Build Slides.pptx
+++ b/Peach State Build Slides.pptx
@@ -7558,14 +7558,110 @@
       </p:sp>
       <p:sp>
         <p:nvSpPr>
-          <p:cNvPr id="5" name="Oval 4"/>
+          <p:cNvPr id="5" name="Rectangle 4"/>
           <p:cNvSpPr/>
           <p:nvPr/>
         </p:nvSpPr>
         <p:spPr>
           <a:xfrm>
-            <a:off x="868680" y="2194560"/>
-            <a:ext cx="457200" cy="457200"/>
+            <a:off x="1005840" y="2834640"/>
+            <a:ext cx="10180015" cy="25400"/>
+          </a:xfrm>
+          <a:prstGeom prst="rect">
+            <a:avLst/>
+          </a:prstGeom>
+          <a:solidFill>
+            <a:srgbClr val="F4F5F6"/>
+          </a:solidFill>
+          <a:ln>
+            <a:noFill/>
+          </a:ln>
+          <a:effectLst/>
+        </p:spPr>
+        <p:style>
+          <a:lnRef idx="1">
+            <a:schemeClr val="accent1"/>
+          </a:lnRef>
+          <a:fillRef idx="3">
+            <a:schemeClr val="accent1"/>
+          </a:fillRef>
+          <a:effectRef idx="2">
+            <a:schemeClr val="accent1"/>
+          </a:effectRef>
+          <a:fontRef idx="minor">
+            <a:schemeClr val="lt1"/>
+          </a:fontRef>
+        </p:style>
+        <p:txBody>
+          <a:bodyPr rtlCol="0" anchor="ctr"/>
+          <a:lstStyle/>
+          <a:p>
+            <a:pPr algn="ctr"/>
+          </a:p>
+        </p:txBody>
+      </p:sp>
+      <p:sp>
+        <p:nvSpPr>
+          <p:cNvPr id="6" name="Rounded Rectangle 5"/>
+          <p:cNvSpPr/>
+          <p:nvPr/>
+        </p:nvSpPr>
+        <p:spPr>
+          <a:xfrm>
+            <a:off x="822960" y="2651760"/>
+            <a:ext cx="3301898" cy="2651760"/>
+          </a:xfrm>
+          <a:prstGeom prst="roundRect">
+            <a:avLst>
+              <a:gd name="adj" fmla="val 4500"/>
+            </a:avLst>
+          </a:prstGeom>
+          <a:solidFill>
+            <a:srgbClr val="F4F5F6"/>
+          </a:solidFill>
+          <a:ln>
+            <a:noFill/>
+          </a:ln>
+          <a:effectLst>
+            <a:outerShdw blurRad="90000" dist="38100" dir="5400000" rotWithShape="0">
+              <a:srgbClr val="1A1D1F">
+                <a:alpha val="22000"/>
+              </a:srgbClr>
+            </a:outerShdw>
+          </a:effectLst>
+        </p:spPr>
+        <p:style>
+          <a:lnRef idx="1">
+            <a:schemeClr val="accent1"/>
+          </a:lnRef>
+          <a:fillRef idx="3">
+            <a:schemeClr val="accent1"/>
+          </a:fillRef>
+          <a:effectRef idx="2">
+            <a:schemeClr val="accent1"/>
+          </a:effectRef>
+          <a:fontRef idx="minor">
+            <a:schemeClr val="lt1"/>
+          </a:fontRef>
+        </p:style>
+        <p:txBody>
+          <a:bodyPr rtlCol="0" anchor="ctr"/>
+          <a:lstStyle/>
+          <a:p>
+            <a:pPr algn="ctr"/>
+          </a:p>
+        </p:txBody>
+      </p:sp>
+      <p:sp>
+        <p:nvSpPr>
+          <p:cNvPr id="7" name="Oval 6"/>
+          <p:cNvSpPr/>
+          <p:nvPr/>
+        </p:nvSpPr>
+        <p:spPr>
+          <a:xfrm>
+            <a:off x="2190445" y="2350008"/>
+            <a:ext cx="566928" cy="566928"/>
           </a:xfrm>
           <a:prstGeom prst="ellipse">
             <a:avLst/>
@@ -7611,14 +7707,14 @@
       </p:sp>
       <p:sp>
         <p:nvSpPr>
-          <p:cNvPr id="6" name="TextBox 5"/>
+          <p:cNvPr id="8" name="TextBox 7"/>
           <p:cNvSpPr txBox="1"/>
           <p:nvPr/>
         </p:nvSpPr>
         <p:spPr>
           <a:xfrm>
-            <a:off x="1554480" y="2148840"/>
-            <a:ext cx="9905695" cy="1005840"/>
+            <a:off x="1143000" y="3337560"/>
+            <a:ext cx="2661818" cy="502920"/>
           </a:xfrm>
           <a:prstGeom prst="rect">
             <a:avLst/>
@@ -7626,17 +7722,17 @@
           <a:noFill/>
         </p:spPr>
         <p:txBody>
-          <a:bodyPr wrap="square" anchor="ctr">
+          <a:bodyPr wrap="square" anchor="t">
             <a:spAutoFit/>
           </a:bodyPr>
           <a:lstStyle/>
           <a:p>
-            <a:pPr algn="l">
+            <a:pPr algn="ctr">
               <a:lnSpc>
                 <a:spcPct val="105000"/>
               </a:lnSpc>
               <a:spcAft>
-                <a:spcPts val="200"/>
+                <a:spcPts val="600"/>
               </a:spcAft>
             </a:pPr>
             <a:r>
@@ -7649,13 +7745,36 @@
               <a:t>Step one</a:t>
             </a:r>
           </a:p>
-          <a:p>
-            <a:pPr algn="l">
+        </p:txBody>
+      </p:sp>
+      <p:sp>
+        <p:nvSpPr>
+          <p:cNvPr id="9" name="TextBox 8"/>
+          <p:cNvSpPr txBox="1"/>
+          <p:nvPr/>
+        </p:nvSpPr>
+        <p:spPr>
+          <a:xfrm>
+            <a:off x="1143000" y="3904488"/>
+            <a:ext cx="2661818" cy="1143000"/>
+          </a:xfrm>
+          <a:prstGeom prst="rect">
+            <a:avLst/>
+          </a:prstGeom>
+          <a:noFill/>
+        </p:spPr>
+        <p:txBody>
+          <a:bodyPr wrap="square" anchor="ctr">
+            <a:spAutoFit/>
+          </a:bodyPr>
+          <a:lstStyle/>
+          <a:p>
+            <a:pPr algn="ctr">
               <a:lnSpc>
                 <a:spcPct val="105000"/>
               </a:lnSpc>
               <a:spcAft>
-                <a:spcPts val="200"/>
+                <a:spcPts val="600"/>
               </a:spcAft>
             </a:pPr>
             <a:r>
@@ -7672,14 +7791,66 @@
       </p:sp>
       <p:sp>
         <p:nvSpPr>
-          <p:cNvPr id="7" name="Oval 6"/>
+          <p:cNvPr id="10" name="Rounded Rectangle 9"/>
           <p:cNvSpPr/>
           <p:nvPr/>
         </p:nvSpPr>
         <p:spPr>
           <a:xfrm>
-            <a:off x="868680" y="3200400"/>
-            <a:ext cx="457200" cy="457200"/>
+            <a:off x="4444898" y="2651760"/>
+            <a:ext cx="3301898" cy="2651760"/>
+          </a:xfrm>
+          <a:prstGeom prst="roundRect">
+            <a:avLst>
+              <a:gd name="adj" fmla="val 4500"/>
+            </a:avLst>
+          </a:prstGeom>
+          <a:solidFill>
+            <a:srgbClr val="F4F5F6"/>
+          </a:solidFill>
+          <a:ln>
+            <a:noFill/>
+          </a:ln>
+          <a:effectLst>
+            <a:outerShdw blurRad="90000" dist="38100" dir="5400000" rotWithShape="0">
+              <a:srgbClr val="1A1D1F">
+                <a:alpha val="22000"/>
+              </a:srgbClr>
+            </a:outerShdw>
+          </a:effectLst>
+        </p:spPr>
+        <p:style>
+          <a:lnRef idx="1">
+            <a:schemeClr val="accent1"/>
+          </a:lnRef>
+          <a:fillRef idx="3">
+            <a:schemeClr val="accent1"/>
+          </a:fillRef>
+          <a:effectRef idx="2">
+            <a:schemeClr val="accent1"/>
+          </a:effectRef>
+          <a:fontRef idx="minor">
+            <a:schemeClr val="lt1"/>
+          </a:fontRef>
+        </p:style>
+        <p:txBody>
+          <a:bodyPr rtlCol="0" anchor="ctr"/>
+          <a:lstStyle/>
+          <a:p>
+            <a:pPr algn="ctr"/>
+          </a:p>
+        </p:txBody>
+      </p:sp>
+      <p:sp>
+        <p:nvSpPr>
+          <p:cNvPr id="11" name="Oval 10"/>
+          <p:cNvSpPr/>
+          <p:nvPr/>
+        </p:nvSpPr>
+        <p:spPr>
+          <a:xfrm>
+            <a:off x="5812383" y="2350008"/>
+            <a:ext cx="566928" cy="566928"/>
           </a:xfrm>
           <a:prstGeom prst="ellipse">
             <a:avLst/>
@@ -7725,14 +7896,14 @@
       </p:sp>
       <p:sp>
         <p:nvSpPr>
-          <p:cNvPr id="8" name="TextBox 7"/>
+          <p:cNvPr id="12" name="TextBox 11"/>
           <p:cNvSpPr txBox="1"/>
           <p:nvPr/>
         </p:nvSpPr>
         <p:spPr>
           <a:xfrm>
-            <a:off x="1554480" y="3154680"/>
-            <a:ext cx="9905695" cy="1005840"/>
+            <a:off x="4764938" y="3337560"/>
+            <a:ext cx="2661818" cy="502920"/>
           </a:xfrm>
           <a:prstGeom prst="rect">
             <a:avLst/>
@@ -7740,17 +7911,17 @@
           <a:noFill/>
         </p:spPr>
         <p:txBody>
-          <a:bodyPr wrap="square" anchor="ctr">
+          <a:bodyPr wrap="square" anchor="t">
             <a:spAutoFit/>
           </a:bodyPr>
           <a:lstStyle/>
           <a:p>
-            <a:pPr algn="l">
+            <a:pPr algn="ctr">
               <a:lnSpc>
                 <a:spcPct val="105000"/>
               </a:lnSpc>
               <a:spcAft>
-                <a:spcPts val="200"/>
+                <a:spcPts val="600"/>
               </a:spcAft>
             </a:pPr>
             <a:r>
@@ -7763,13 +7934,36 @@
               <a:t>Step two</a:t>
             </a:r>
           </a:p>
-          <a:p>
-            <a:pPr algn="l">
+        </p:txBody>
+      </p:sp>
+      <p:sp>
+        <p:nvSpPr>
+          <p:cNvPr id="13" name="TextBox 12"/>
+          <p:cNvSpPr txBox="1"/>
+          <p:nvPr/>
+        </p:nvSpPr>
+        <p:spPr>
+          <a:xfrm>
+            <a:off x="4764938" y="3904488"/>
+            <a:ext cx="2661818" cy="1143000"/>
+          </a:xfrm>
+          <a:prstGeom prst="rect">
+            <a:avLst/>
+          </a:prstGeom>
+          <a:noFill/>
+        </p:spPr>
+        <p:txBody>
+          <a:bodyPr wrap="square" anchor="ctr">
+            <a:spAutoFit/>
+          </a:bodyPr>
+          <a:lstStyle/>
+          <a:p>
+            <a:pPr algn="ctr">
               <a:lnSpc>
                 <a:spcPct val="105000"/>
               </a:lnSpc>
               <a:spcAft>
-                <a:spcPts val="200"/>
+                <a:spcPts val="600"/>
               </a:spcAft>
             </a:pPr>
             <a:r>
@@ -7786,14 +7980,66 @@
       </p:sp>
       <p:sp>
         <p:nvSpPr>
-          <p:cNvPr id="9" name="Oval 8"/>
+          <p:cNvPr id="14" name="Rounded Rectangle 13"/>
           <p:cNvSpPr/>
           <p:nvPr/>
         </p:nvSpPr>
         <p:spPr>
           <a:xfrm>
-            <a:off x="868680" y="4206240"/>
-            <a:ext cx="457200" cy="457200"/>
+            <a:off x="8066836" y="2651760"/>
+            <a:ext cx="3301898" cy="2651760"/>
+          </a:xfrm>
+          <a:prstGeom prst="roundRect">
+            <a:avLst>
+              <a:gd name="adj" fmla="val 4500"/>
+            </a:avLst>
+          </a:prstGeom>
+          <a:solidFill>
+            <a:srgbClr val="F4F5F6"/>
+          </a:solidFill>
+          <a:ln>
+            <a:noFill/>
+          </a:ln>
+          <a:effectLst>
+            <a:outerShdw blurRad="90000" dist="38100" dir="5400000" rotWithShape="0">
+              <a:srgbClr val="1A1D1F">
+                <a:alpha val="22000"/>
+              </a:srgbClr>
+            </a:outerShdw>
+          </a:effectLst>
+        </p:spPr>
+        <p:style>
+          <a:lnRef idx="1">
+            <a:schemeClr val="accent1"/>
+          </a:lnRef>
+          <a:fillRef idx="3">
+            <a:schemeClr val="accent1"/>
+          </a:fillRef>
+          <a:effectRef idx="2">
+            <a:schemeClr val="accent1"/>
+          </a:effectRef>
+          <a:fontRef idx="minor">
+            <a:schemeClr val="lt1"/>
+          </a:fontRef>
+        </p:style>
+        <p:txBody>
+          <a:bodyPr rtlCol="0" anchor="ctr"/>
+          <a:lstStyle/>
+          <a:p>
+            <a:pPr algn="ctr"/>
+          </a:p>
+        </p:txBody>
+      </p:sp>
+      <p:sp>
+        <p:nvSpPr>
+          <p:cNvPr id="15" name="Oval 14"/>
+          <p:cNvSpPr/>
+          <p:nvPr/>
+        </p:nvSpPr>
+        <p:spPr>
+          <a:xfrm>
+            <a:off x="9434321" y="2350008"/>
+            <a:ext cx="566928" cy="566928"/>
           </a:xfrm>
           <a:prstGeom prst="ellipse">
             <a:avLst/>
@@ -7839,14 +8085,14 @@
       </p:sp>
       <p:sp>
         <p:nvSpPr>
-          <p:cNvPr id="10" name="TextBox 9"/>
+          <p:cNvPr id="16" name="TextBox 15"/>
           <p:cNvSpPr txBox="1"/>
           <p:nvPr/>
         </p:nvSpPr>
         <p:spPr>
           <a:xfrm>
-            <a:off x="1554480" y="4160520"/>
-            <a:ext cx="9905695" cy="1005840"/>
+            <a:off x="8386876" y="3337560"/>
+            <a:ext cx="2661818" cy="502920"/>
           </a:xfrm>
           <a:prstGeom prst="rect">
             <a:avLst/>
@@ -7854,17 +8100,17 @@
           <a:noFill/>
         </p:spPr>
         <p:txBody>
-          <a:bodyPr wrap="square" anchor="ctr">
+          <a:bodyPr wrap="square" anchor="t">
             <a:spAutoFit/>
           </a:bodyPr>
           <a:lstStyle/>
           <a:p>
-            <a:pPr algn="l">
+            <a:pPr algn="ctr">
               <a:lnSpc>
                 <a:spcPct val="105000"/>
               </a:lnSpc>
               <a:spcAft>
-                <a:spcPts val="200"/>
+                <a:spcPts val="600"/>
               </a:spcAft>
             </a:pPr>
             <a:r>
@@ -7877,13 +8123,36 @@
               <a:t>Step three</a:t>
             </a:r>
           </a:p>
-          <a:p>
-            <a:pPr algn="l">
+        </p:txBody>
+      </p:sp>
+      <p:sp>
+        <p:nvSpPr>
+          <p:cNvPr id="17" name="TextBox 16"/>
+          <p:cNvSpPr txBox="1"/>
+          <p:nvPr/>
+        </p:nvSpPr>
+        <p:spPr>
+          <a:xfrm>
+            <a:off x="8386876" y="3904488"/>
+            <a:ext cx="2661818" cy="1143000"/>
+          </a:xfrm>
+          <a:prstGeom prst="rect">
+            <a:avLst/>
+          </a:prstGeom>
+          <a:noFill/>
+        </p:spPr>
+        <p:txBody>
+          <a:bodyPr wrap="square" anchor="ctr">
+            <a:spAutoFit/>
+          </a:bodyPr>
+          <a:lstStyle/>
+          <a:p>
+            <a:pPr algn="ctr">
               <a:lnSpc>
                 <a:spcPct val="105000"/>
               </a:lnSpc>
               <a:spcAft>
-                <a:spcPts val="200"/>
+                <a:spcPts val="600"/>
               </a:spcAft>
             </a:pPr>
             <a:r>

</xml_diff>